<commit_message>
Deck: sharper 2x screenshots, larger agent screenshot, team names
Screenshots recaptured at 2x device pixel ratio, cropped tighter and embedded
at near-native resolution (JPEG q92, 4:4:4) so UI text stays legible when
slides are enlarged. Team: Kris Keshav, Shivam Bansal (IIT Roorkee).
</commit_message>
<xml_diff>
--- a/deck/KhetDrishti_pitch.pptx
+++ b/deck/KhetDrishti_pitch.pptx
@@ -1084,7 +1084,7 @@
           <a:p>
             <a:r>
               <a:rPr lang="en-US" dirty="0"/>
-              <a:t>Explicit state machine: plan, act (parallel tools), draft, verify, self-correct, translate. The screenshot is a real Hindi answer: 6 numbers verified against live data, 2 tool calls, 2.8 s, with the live trace on the right.</a:t>
+              <a:t>Explicit state machine: plan, act (parallel tools), draft, verify, self-correct, translate. The screenshot is a real Hindi answer: 4 numbers verified against live data, 2 tool calls, 2.8 s, with the live trace on the right.</a:t>
             </a:r>
             <a:endParaRPr lang="en-US" dirty="0"/>
           </a:p>
@@ -2468,7 +2468,7 @@
                 <a:ea typeface="Calibri" pitchFamily="34" charset="-122"/>
                 <a:cs typeface="Calibri" pitchFamily="34" charset="-120"/>
               </a:rPr>
-              <a:t>Team: Kris Keshav (IIT Roorkee)</a:t>
+              <a:t>Team: Kris Keshav · Shivam Bansal (IIT Roorkee)</a:t>
             </a:r>
             <a:endParaRPr lang="en-US" sz="1300" dirty="0"/>
           </a:p>
@@ -2483,11 +2483,11 @@
         <p:spPr>
           <a:xfrm>
             <a:off x="6757416" y="950976"/>
-            <a:ext cx="5001768" cy="2861501"/>
+            <a:ext cx="5001768" cy="3167253"/>
           </a:xfrm>
           <a:prstGeom prst="roundRect">
             <a:avLst>
-              <a:gd name="adj" fmla="val 2556"/>
+              <a:gd name="adj" fmla="val 2310"/>
             </a:avLst>
           </a:prstGeom>
           <a:solidFill>
@@ -2525,7 +2525,7 @@
         <p:spPr>
           <a:xfrm>
             <a:off x="6812280" y="1005840"/>
-            <a:ext cx="4892040" cy="2751773"/>
+            <a:ext cx="4892040" cy="3057525"/>
           </a:xfrm>
           <a:prstGeom prst="rect">
             <a:avLst/>
@@ -3494,11 +3494,11 @@
         <p:spPr>
           <a:xfrm>
             <a:off x="493776" y="1271016"/>
-            <a:ext cx="5687568" cy="1795033"/>
+            <a:ext cx="5687568" cy="2182336"/>
           </a:xfrm>
           <a:prstGeom prst="roundRect">
             <a:avLst>
-              <a:gd name="adj" fmla="val 4075"/>
+              <a:gd name="adj" fmla="val 3352"/>
             </a:avLst>
           </a:prstGeom>
           <a:solidFill>
@@ -3536,7 +3536,7 @@
         <p:spPr>
           <a:xfrm>
             <a:off x="548640" y="1325880"/>
-            <a:ext cx="5577840" cy="1685305"/>
+            <a:ext cx="5577840" cy="2072608"/>
           </a:xfrm>
           <a:prstGeom prst="rect">
             <a:avLst/>
@@ -3551,12 +3551,12 @@
         </p:nvSpPr>
         <p:spPr>
           <a:xfrm>
-            <a:off x="493776" y="3230641"/>
-            <a:ext cx="5687568" cy="2380706"/>
+            <a:off x="513119" y="3617944"/>
+            <a:ext cx="5648882" cy="2990088"/>
           </a:xfrm>
           <a:prstGeom prst="roundRect">
             <a:avLst>
-              <a:gd name="adj" fmla="val 3073"/>
+              <a:gd name="adj" fmla="val 2446"/>
             </a:avLst>
           </a:prstGeom>
           <a:solidFill>
@@ -3593,8 +3593,8 @@
         </p:blipFill>
         <p:spPr>
           <a:xfrm>
-            <a:off x="548640" y="3285505"/>
-            <a:ext cx="5577840" cy="2270978"/>
+            <a:off x="567983" y="3672808"/>
+            <a:ext cx="5539154" cy="2880360"/>
           </a:xfrm>
           <a:prstGeom prst="rect">
             <a:avLst/>
@@ -4647,12 +4647,12 @@
         </p:nvSpPr>
         <p:spPr>
           <a:xfrm>
-            <a:off x="548640" y="1325880"/>
-            <a:ext cx="1965960" cy="1600200"/>
+            <a:off x="548640" y="1280160"/>
+            <a:ext cx="1965960" cy="1371600"/>
           </a:xfrm>
           <a:prstGeom prst="roundRect">
             <a:avLst>
-              <a:gd name="adj" fmla="val 6857"/>
+              <a:gd name="adj" fmla="val 8000"/>
             </a:avLst>
           </a:prstGeom>
           <a:solidFill>
@@ -4674,8 +4674,8 @@
         </p:nvSpPr>
         <p:spPr>
           <a:xfrm>
-            <a:off x="1234440" y="1417320"/>
-            <a:ext cx="566928" cy="566928"/>
+            <a:off x="1271016" y="1371600"/>
+            <a:ext cx="512064" cy="512064"/>
           </a:xfrm>
           <a:prstGeom prst="ellipse">
             <a:avLst/>
@@ -4707,8 +4707,8 @@
         </p:blipFill>
         <p:spPr>
           <a:xfrm>
-            <a:off x="1376172" y="1559052"/>
-            <a:ext cx="283464" cy="283464"/>
+            <a:off x="1399032" y="1499616"/>
+            <a:ext cx="256032" cy="256032"/>
           </a:xfrm>
           <a:prstGeom prst="rect">
             <a:avLst/>
@@ -4723,7 +4723,7 @@
         </p:nvSpPr>
         <p:spPr>
           <a:xfrm>
-            <a:off x="640080" y="2057400"/>
+            <a:off x="640080" y="1938528"/>
             <a:ext cx="1783080" cy="320040"/>
           </a:xfrm>
           <a:prstGeom prst="rect">
@@ -4762,8 +4762,8 @@
         </p:nvSpPr>
         <p:spPr>
           <a:xfrm>
-            <a:off x="640080" y="2377440"/>
-            <a:ext cx="1783080" cy="502920"/>
+            <a:off x="640080" y="2249424"/>
+            <a:ext cx="1783080" cy="384048"/>
           </a:xfrm>
           <a:prstGeom prst="rect">
             <a:avLst/>
@@ -4809,7 +4809,7 @@
         </p:blipFill>
         <p:spPr>
           <a:xfrm>
-            <a:off x="2560320" y="1965960"/>
+            <a:off x="2560320" y="1847088"/>
             <a:ext cx="237744" cy="237744"/>
           </a:xfrm>
           <a:prstGeom prst="rect">
@@ -4825,12 +4825,12 @@
         </p:nvSpPr>
         <p:spPr>
           <a:xfrm>
-            <a:off x="2834640" y="1325880"/>
-            <a:ext cx="1965960" cy="1600200"/>
+            <a:off x="2834640" y="1280160"/>
+            <a:ext cx="1965960" cy="1371600"/>
           </a:xfrm>
           <a:prstGeom prst="roundRect">
             <a:avLst>
-              <a:gd name="adj" fmla="val 6857"/>
+              <a:gd name="adj" fmla="val 8000"/>
             </a:avLst>
           </a:prstGeom>
           <a:solidFill>
@@ -4852,8 +4852,8 @@
         </p:nvSpPr>
         <p:spPr>
           <a:xfrm>
-            <a:off x="3520440" y="1417320"/>
-            <a:ext cx="566928" cy="566928"/>
+            <a:off x="3557016" y="1371600"/>
+            <a:ext cx="512064" cy="512064"/>
           </a:xfrm>
           <a:prstGeom prst="ellipse">
             <a:avLst/>
@@ -4885,8 +4885,8 @@
         </p:blipFill>
         <p:spPr>
           <a:xfrm>
-            <a:off x="3662172" y="1559052"/>
-            <a:ext cx="283464" cy="283464"/>
+            <a:off x="3685032" y="1499616"/>
+            <a:ext cx="256032" cy="256032"/>
           </a:xfrm>
           <a:prstGeom prst="rect">
             <a:avLst/>
@@ -4901,7 +4901,7 @@
         </p:nvSpPr>
         <p:spPr>
           <a:xfrm>
-            <a:off x="2926080" y="2057400"/>
+            <a:off x="2926080" y="1938528"/>
             <a:ext cx="1783080" cy="320040"/>
           </a:xfrm>
           <a:prstGeom prst="rect">
@@ -4940,8 +4940,8 @@
         </p:nvSpPr>
         <p:spPr>
           <a:xfrm>
-            <a:off x="2926080" y="2377440"/>
-            <a:ext cx="1783080" cy="502920"/>
+            <a:off x="2926080" y="2249424"/>
+            <a:ext cx="1783080" cy="384048"/>
           </a:xfrm>
           <a:prstGeom prst="rect">
             <a:avLst/>
@@ -4987,7 +4987,7 @@
         </p:blipFill>
         <p:spPr>
           <a:xfrm>
-            <a:off x="4846320" y="1965960"/>
+            <a:off x="4846320" y="1847088"/>
             <a:ext cx="237744" cy="237744"/>
           </a:xfrm>
           <a:prstGeom prst="rect">
@@ -5003,12 +5003,12 @@
         </p:nvSpPr>
         <p:spPr>
           <a:xfrm>
-            <a:off x="5120640" y="1325880"/>
-            <a:ext cx="1965960" cy="1600200"/>
+            <a:off x="5120640" y="1280160"/>
+            <a:ext cx="1965960" cy="1371600"/>
           </a:xfrm>
           <a:prstGeom prst="roundRect">
             <a:avLst>
-              <a:gd name="adj" fmla="val 6857"/>
+              <a:gd name="adj" fmla="val 8000"/>
             </a:avLst>
           </a:prstGeom>
           <a:solidFill>
@@ -5030,8 +5030,8 @@
         </p:nvSpPr>
         <p:spPr>
           <a:xfrm>
-            <a:off x="5806440" y="1417320"/>
-            <a:ext cx="566928" cy="566928"/>
+            <a:off x="5843016" y="1371600"/>
+            <a:ext cx="512064" cy="512064"/>
           </a:xfrm>
           <a:prstGeom prst="ellipse">
             <a:avLst/>
@@ -5063,8 +5063,8 @@
         </p:blipFill>
         <p:spPr>
           <a:xfrm>
-            <a:off x="5948172" y="1559052"/>
-            <a:ext cx="283464" cy="283464"/>
+            <a:off x="5971032" y="1499616"/>
+            <a:ext cx="256032" cy="256032"/>
           </a:xfrm>
           <a:prstGeom prst="rect">
             <a:avLst/>
@@ -5079,7 +5079,7 @@
         </p:nvSpPr>
         <p:spPr>
           <a:xfrm>
-            <a:off x="5212080" y="2057400"/>
+            <a:off x="5212080" y="1938528"/>
             <a:ext cx="1783080" cy="320040"/>
           </a:xfrm>
           <a:prstGeom prst="rect">
@@ -5118,8 +5118,8 @@
         </p:nvSpPr>
         <p:spPr>
           <a:xfrm>
-            <a:off x="5212080" y="2377440"/>
-            <a:ext cx="1783080" cy="502920"/>
+            <a:off x="5212080" y="2249424"/>
+            <a:ext cx="1783080" cy="384048"/>
           </a:xfrm>
           <a:prstGeom prst="rect">
             <a:avLst/>
@@ -5165,7 +5165,7 @@
         </p:blipFill>
         <p:spPr>
           <a:xfrm>
-            <a:off x="7132320" y="1965960"/>
+            <a:off x="7132320" y="1847088"/>
             <a:ext cx="237744" cy="237744"/>
           </a:xfrm>
           <a:prstGeom prst="rect">
@@ -5181,12 +5181,12 @@
         </p:nvSpPr>
         <p:spPr>
           <a:xfrm>
-            <a:off x="7406640" y="1325880"/>
-            <a:ext cx="1965960" cy="1600200"/>
+            <a:off x="7406640" y="1280160"/>
+            <a:ext cx="1965960" cy="1371600"/>
           </a:xfrm>
           <a:prstGeom prst="roundRect">
             <a:avLst>
-              <a:gd name="adj" fmla="val 6857"/>
+              <a:gd name="adj" fmla="val 8000"/>
             </a:avLst>
           </a:prstGeom>
           <a:solidFill>
@@ -5208,8 +5208,8 @@
         </p:nvSpPr>
         <p:spPr>
           <a:xfrm>
-            <a:off x="8092440" y="1417320"/>
-            <a:ext cx="566928" cy="566928"/>
+            <a:off x="8129016" y="1371600"/>
+            <a:ext cx="512064" cy="512064"/>
           </a:xfrm>
           <a:prstGeom prst="ellipse">
             <a:avLst/>
@@ -5241,8 +5241,8 @@
         </p:blipFill>
         <p:spPr>
           <a:xfrm>
-            <a:off x="8234172" y="1559052"/>
-            <a:ext cx="283464" cy="283464"/>
+            <a:off x="8257032" y="1499616"/>
+            <a:ext cx="256032" cy="256032"/>
           </a:xfrm>
           <a:prstGeom prst="rect">
             <a:avLst/>
@@ -5257,7 +5257,7 @@
         </p:nvSpPr>
         <p:spPr>
           <a:xfrm>
-            <a:off x="7498080" y="2057400"/>
+            <a:off x="7498080" y="1938528"/>
             <a:ext cx="1783080" cy="320040"/>
           </a:xfrm>
           <a:prstGeom prst="rect">
@@ -5296,8 +5296,8 @@
         </p:nvSpPr>
         <p:spPr>
           <a:xfrm>
-            <a:off x="7498080" y="2377440"/>
-            <a:ext cx="1783080" cy="502920"/>
+            <a:off x="7498080" y="2249424"/>
+            <a:ext cx="1783080" cy="384048"/>
           </a:xfrm>
           <a:prstGeom prst="rect">
             <a:avLst/>
@@ -5343,7 +5343,7 @@
         </p:blipFill>
         <p:spPr>
           <a:xfrm>
-            <a:off x="9418320" y="1965960"/>
+            <a:off x="9418320" y="1847088"/>
             <a:ext cx="237744" cy="237744"/>
           </a:xfrm>
           <a:prstGeom prst="rect">
@@ -5359,12 +5359,12 @@
         </p:nvSpPr>
         <p:spPr>
           <a:xfrm>
-            <a:off x="9692640" y="1325880"/>
-            <a:ext cx="1965960" cy="1600200"/>
+            <a:off x="9692640" y="1280160"/>
+            <a:ext cx="1965960" cy="1371600"/>
           </a:xfrm>
           <a:prstGeom prst="roundRect">
             <a:avLst>
-              <a:gd name="adj" fmla="val 6857"/>
+              <a:gd name="adj" fmla="val 8000"/>
             </a:avLst>
           </a:prstGeom>
           <a:solidFill>
@@ -5386,8 +5386,8 @@
         </p:nvSpPr>
         <p:spPr>
           <a:xfrm>
-            <a:off x="10378440" y="1417320"/>
-            <a:ext cx="566928" cy="566928"/>
+            <a:off x="10415016" y="1371600"/>
+            <a:ext cx="512064" cy="512064"/>
           </a:xfrm>
           <a:prstGeom prst="ellipse">
             <a:avLst/>
@@ -5419,8 +5419,8 @@
         </p:blipFill>
         <p:spPr>
           <a:xfrm>
-            <a:off x="10520172" y="1559052"/>
-            <a:ext cx="283464" cy="283464"/>
+            <a:off x="10543032" y="1499616"/>
+            <a:ext cx="256032" cy="256032"/>
           </a:xfrm>
           <a:prstGeom prst="rect">
             <a:avLst/>
@@ -5435,7 +5435,7 @@
         </p:nvSpPr>
         <p:spPr>
           <a:xfrm>
-            <a:off x="9784080" y="2057400"/>
+            <a:off x="9784080" y="1938528"/>
             <a:ext cx="1783080" cy="320040"/>
           </a:xfrm>
           <a:prstGeom prst="rect">
@@ -5474,8 +5474,8 @@
         </p:nvSpPr>
         <p:spPr>
           <a:xfrm>
-            <a:off x="9784080" y="2377440"/>
-            <a:ext cx="1783080" cy="502920"/>
+            <a:off x="9784080" y="2249424"/>
+            <a:ext cx="1783080" cy="384048"/>
           </a:xfrm>
           <a:prstGeom prst="rect">
             <a:avLst/>
@@ -5521,8 +5521,8 @@
         </p:blipFill>
         <p:spPr>
           <a:xfrm>
-            <a:off x="7680960" y="3035808"/>
-            <a:ext cx="274320" cy="274320"/>
+            <a:off x="548640" y="2779776"/>
+            <a:ext cx="256032" cy="256032"/>
           </a:xfrm>
           <a:prstGeom prst="rect">
             <a:avLst/>
@@ -5537,8 +5537,8 @@
         </p:nvSpPr>
         <p:spPr>
           <a:xfrm>
-            <a:off x="8046720" y="2990088"/>
-            <a:ext cx="3611880" cy="411480"/>
+            <a:off x="896112" y="2761488"/>
+            <a:ext cx="10698480" cy="292608"/>
           </a:xfrm>
           <a:prstGeom prst="rect">
             <a:avLst/>
@@ -5554,7 +5554,7 @@
               <a:buNone/>
             </a:pPr>
             <a:r>
-              <a:rPr lang="en-US" sz="1100" i="1" dirty="0">
+              <a:rPr lang="en-US" sz="1200" i="1" dirty="0">
                 <a:solidFill>
                   <a:srgbClr val="E8962E"/>
                 </a:solidFill>
@@ -5564,7 +5564,7 @@
               </a:rPr>
               <a:t>Fails? The agent is told exactly which number failed and rewrites; anything still unverifiable is removed.</a:t>
             </a:r>
-            <a:endParaRPr lang="en-US" sz="1100" dirty="0"/>
+            <a:endParaRPr lang="en-US" sz="1200" dirty="0"/>
           </a:p>
         </p:txBody>
       </p:sp>
@@ -5576,7 +5576,7 @@
         </p:nvSpPr>
         <p:spPr>
           <a:xfrm>
-            <a:off x="548640" y="3657600"/>
+            <a:off x="548640" y="3337560"/>
             <a:ext cx="475488" cy="475488"/>
           </a:xfrm>
           <a:prstGeom prst="ellipse">
@@ -5609,7 +5609,7 @@
         </p:blipFill>
         <p:spPr>
           <a:xfrm>
-            <a:off x="667512" y="3776472"/>
+            <a:off x="667512" y="3456432"/>
             <a:ext cx="237744" cy="237744"/>
           </a:xfrm>
           <a:prstGeom prst="rect">
@@ -5625,8 +5625,8 @@
         </p:nvSpPr>
         <p:spPr>
           <a:xfrm>
-            <a:off x="1188720" y="3621024"/>
-            <a:ext cx="5120640" cy="594360"/>
+            <a:off x="1188720" y="3282696"/>
+            <a:ext cx="5374530" cy="640080"/>
           </a:xfrm>
           <a:prstGeom prst="rect">
             <a:avLst/>
@@ -5678,7 +5678,7 @@
         </p:nvSpPr>
         <p:spPr>
           <a:xfrm>
-            <a:off x="548640" y="4343400"/>
+            <a:off x="548640" y="4087368"/>
             <a:ext cx="475488" cy="475488"/>
           </a:xfrm>
           <a:prstGeom prst="ellipse">
@@ -5711,7 +5711,7 @@
         </p:blipFill>
         <p:spPr>
           <a:xfrm>
-            <a:off x="667512" y="4462272"/>
+            <a:off x="667512" y="4206240"/>
             <a:ext cx="237744" cy="237744"/>
           </a:xfrm>
           <a:prstGeom prst="rect">
@@ -5727,8 +5727,8 @@
         </p:nvSpPr>
         <p:spPr>
           <a:xfrm>
-            <a:off x="1188720" y="4306824"/>
-            <a:ext cx="5120640" cy="594360"/>
+            <a:off x="1188720" y="4032504"/>
+            <a:ext cx="5374530" cy="640080"/>
           </a:xfrm>
           <a:prstGeom prst="rect">
             <a:avLst/>
@@ -5780,7 +5780,7 @@
         </p:nvSpPr>
         <p:spPr>
           <a:xfrm>
-            <a:off x="548640" y="5029200"/>
+            <a:off x="548640" y="4837176"/>
             <a:ext cx="475488" cy="475488"/>
           </a:xfrm>
           <a:prstGeom prst="ellipse">
@@ -5813,7 +5813,7 @@
         </p:blipFill>
         <p:spPr>
           <a:xfrm>
-            <a:off x="667512" y="5148072"/>
+            <a:off x="667512" y="4956048"/>
             <a:ext cx="237744" cy="237744"/>
           </a:xfrm>
           <a:prstGeom prst="rect">
@@ -5829,8 +5829,8 @@
         </p:nvSpPr>
         <p:spPr>
           <a:xfrm>
-            <a:off x="1188720" y="4992624"/>
-            <a:ext cx="5120640" cy="594360"/>
+            <a:off x="1188720" y="4782312"/>
+            <a:ext cx="5374530" cy="640080"/>
           </a:xfrm>
           <a:prstGeom prst="rect">
             <a:avLst/>
@@ -5882,7 +5882,7 @@
         </p:nvSpPr>
         <p:spPr>
           <a:xfrm>
-            <a:off x="548640" y="5715000"/>
+            <a:off x="548640" y="5586984"/>
             <a:ext cx="475488" cy="475488"/>
           </a:xfrm>
           <a:prstGeom prst="ellipse">
@@ -5915,7 +5915,7 @@
         </p:blipFill>
         <p:spPr>
           <a:xfrm>
-            <a:off x="667512" y="5833872"/>
+            <a:off x="667512" y="5705856"/>
             <a:ext cx="237744" cy="237744"/>
           </a:xfrm>
           <a:prstGeom prst="rect">
@@ -5931,8 +5931,8 @@
         </p:nvSpPr>
         <p:spPr>
           <a:xfrm>
-            <a:off x="1188720" y="5678424"/>
-            <a:ext cx="5120640" cy="594360"/>
+            <a:off x="1188720" y="5532120"/>
+            <a:ext cx="5374530" cy="640080"/>
           </a:xfrm>
           <a:prstGeom prst="rect">
             <a:avLst/>
@@ -5984,12 +5984,12 @@
         </p:nvSpPr>
         <p:spPr>
           <a:xfrm>
-            <a:off x="6848856" y="3557016"/>
-            <a:ext cx="4681728" cy="2784348"/>
+            <a:off x="6736986" y="3191256"/>
+            <a:ext cx="4976478" cy="3236976"/>
           </a:xfrm>
           <a:prstGeom prst="roundRect">
             <a:avLst>
-              <a:gd name="adj" fmla="val 2627"/>
+              <a:gd name="adj" fmla="val 2260"/>
             </a:avLst>
           </a:prstGeom>
           <a:solidFill>
@@ -6026,8 +6026,8 @@
         </p:blipFill>
         <p:spPr>
           <a:xfrm>
-            <a:off x="6903720" y="3611880"/>
-            <a:ext cx="4572000" cy="2674620"/>
+            <a:off x="6791850" y="3246120"/>
+            <a:ext cx="4866750" cy="3127248"/>
           </a:xfrm>
           <a:prstGeom prst="rect">
             <a:avLst/>
@@ -7603,12 +7603,12 @@
         </p:nvSpPr>
         <p:spPr>
           <a:xfrm>
-            <a:off x="7488936" y="2825496"/>
-            <a:ext cx="4178808" cy="2400039"/>
+            <a:off x="7351776" y="2825496"/>
+            <a:ext cx="4315968" cy="2110556"/>
           </a:xfrm>
           <a:prstGeom prst="roundRect">
             <a:avLst>
-              <a:gd name="adj" fmla="val 3048"/>
+              <a:gd name="adj" fmla="val 3466"/>
             </a:avLst>
           </a:prstGeom>
           <a:solidFill>
@@ -7645,8 +7645,8 @@
         </p:blipFill>
         <p:spPr>
           <a:xfrm>
-            <a:off x="7543800" y="2880360"/>
-            <a:ext cx="4069080" cy="2290311"/>
+            <a:off x="7406640" y="2880360"/>
+            <a:ext cx="4206240" cy="2000828"/>
           </a:xfrm>
           <a:prstGeom prst="rect">
             <a:avLst/>
@@ -7661,8 +7661,8 @@
         </p:nvSpPr>
         <p:spPr>
           <a:xfrm>
-            <a:off x="7543800" y="5262111"/>
-            <a:ext cx="4069080" cy="685800"/>
+            <a:off x="7406640" y="5018348"/>
+            <a:ext cx="4206240" cy="685800"/>
           </a:xfrm>
           <a:prstGeom prst="rect">
             <a:avLst/>

</xml_diff>